<commit_message>
Update presentatie - toevoeging van varianten
</commit_message>
<xml_diff>
--- a/werkomgeving/presentaties/Dienstbetrekking FBM en MIM 2.0.pptx
+++ b/werkomgeving/presentaties/Dienstbetrekking FBM en MIM 2.0.pptx
@@ -6,10 +6,14 @@
   </p:sldMasterIdLst>
   <p:sldIdLst>
     <p:sldId id="256" r:id="rId2"/>
-    <p:sldId id="257" r:id="rId3"/>
-    <p:sldId id="258" r:id="rId4"/>
-    <p:sldId id="259" r:id="rId5"/>
-    <p:sldId id="260" r:id="rId6"/>
+    <p:sldId id="262" r:id="rId3"/>
+    <p:sldId id="257" r:id="rId4"/>
+    <p:sldId id="261" r:id="rId5"/>
+    <p:sldId id="258" r:id="rId6"/>
+    <p:sldId id="263" r:id="rId7"/>
+    <p:sldId id="264" r:id="rId8"/>
+    <p:sldId id="259" r:id="rId9"/>
+    <p:sldId id="260" r:id="rId10"/>
   </p:sldIdLst>
   <p:sldSz cx="12192000" cy="6858000"/>
   <p:notesSz cx="6858000" cy="9144000"/>
@@ -108,6 +112,11 @@
       </a:defRPr>
     </a:lvl9pPr>
   </p:defaultTextStyle>
+  <p:extLst>
+    <p:ext uri="{EFAFB233-063F-42B5-8137-9DF3F51BA10A}">
+      <p15:sldGuideLst xmlns:p15="http://schemas.microsoft.com/office/powerpoint/2012/main"/>
+    </p:ext>
+  </p:extLst>
 </p:presentation>
 </file>
 
@@ -260,7 +269,7 @@
           <a:p>
             <a:fld id="{5C634AAC-F929-794D-9D03-D362D65357EB}" type="datetimeFigureOut">
               <a:rPr lang="en-NL" smtClean="0"/>
-              <a:t>07/10/2026</a:t>
+              <a:t>10/10/2026</a:t>
             </a:fld>
             <a:endParaRPr lang="en-NL"/>
           </a:p>
@@ -460,7 +469,7 @@
           <a:p>
             <a:fld id="{5C634AAC-F929-794D-9D03-D362D65357EB}" type="datetimeFigureOut">
               <a:rPr lang="en-NL" smtClean="0"/>
-              <a:t>07/10/2026</a:t>
+              <a:t>10/10/2026</a:t>
             </a:fld>
             <a:endParaRPr lang="en-NL"/>
           </a:p>
@@ -670,7 +679,7 @@
           <a:p>
             <a:fld id="{5C634AAC-F929-794D-9D03-D362D65357EB}" type="datetimeFigureOut">
               <a:rPr lang="en-NL" smtClean="0"/>
-              <a:t>07/10/2026</a:t>
+              <a:t>10/10/2026</a:t>
             </a:fld>
             <a:endParaRPr lang="en-NL"/>
           </a:p>
@@ -870,7 +879,7 @@
           <a:p>
             <a:fld id="{5C634AAC-F929-794D-9D03-D362D65357EB}" type="datetimeFigureOut">
               <a:rPr lang="en-NL" smtClean="0"/>
-              <a:t>07/10/2026</a:t>
+              <a:t>10/10/2026</a:t>
             </a:fld>
             <a:endParaRPr lang="en-NL"/>
           </a:p>
@@ -1146,7 +1155,7 @@
           <a:p>
             <a:fld id="{5C634AAC-F929-794D-9D03-D362D65357EB}" type="datetimeFigureOut">
               <a:rPr lang="en-NL" smtClean="0"/>
-              <a:t>07/10/2026</a:t>
+              <a:t>10/10/2026</a:t>
             </a:fld>
             <a:endParaRPr lang="en-NL"/>
           </a:p>
@@ -1414,7 +1423,7 @@
           <a:p>
             <a:fld id="{5C634AAC-F929-794D-9D03-D362D65357EB}" type="datetimeFigureOut">
               <a:rPr lang="en-NL" smtClean="0"/>
-              <a:t>07/10/2026</a:t>
+              <a:t>10/10/2026</a:t>
             </a:fld>
             <a:endParaRPr lang="en-NL"/>
           </a:p>
@@ -1829,7 +1838,7 @@
           <a:p>
             <a:fld id="{5C634AAC-F929-794D-9D03-D362D65357EB}" type="datetimeFigureOut">
               <a:rPr lang="en-NL" smtClean="0"/>
-              <a:t>07/10/2026</a:t>
+              <a:t>10/10/2026</a:t>
             </a:fld>
             <a:endParaRPr lang="en-NL"/>
           </a:p>
@@ -1971,7 +1980,7 @@
           <a:p>
             <a:fld id="{5C634AAC-F929-794D-9D03-D362D65357EB}" type="datetimeFigureOut">
               <a:rPr lang="en-NL" smtClean="0"/>
-              <a:t>07/10/2026</a:t>
+              <a:t>10/10/2026</a:t>
             </a:fld>
             <a:endParaRPr lang="en-NL"/>
           </a:p>
@@ -2084,7 +2093,7 @@
           <a:p>
             <a:fld id="{5C634AAC-F929-794D-9D03-D362D65357EB}" type="datetimeFigureOut">
               <a:rPr lang="en-NL" smtClean="0"/>
-              <a:t>07/10/2026</a:t>
+              <a:t>10/10/2026</a:t>
             </a:fld>
             <a:endParaRPr lang="en-NL"/>
           </a:p>
@@ -2397,7 +2406,7 @@
           <a:p>
             <a:fld id="{5C634AAC-F929-794D-9D03-D362D65357EB}" type="datetimeFigureOut">
               <a:rPr lang="en-NL" smtClean="0"/>
-              <a:t>07/10/2026</a:t>
+              <a:t>10/10/2026</a:t>
             </a:fld>
             <a:endParaRPr lang="en-NL"/>
           </a:p>
@@ -2686,7 +2695,7 @@
           <a:p>
             <a:fld id="{5C634AAC-F929-794D-9D03-D362D65357EB}" type="datetimeFigureOut">
               <a:rPr lang="en-NL" smtClean="0"/>
-              <a:t>07/10/2026</a:t>
+              <a:t>10/10/2026</a:t>
             </a:fld>
             <a:endParaRPr lang="en-NL"/>
           </a:p>
@@ -2929,7 +2938,7 @@
           <a:p>
             <a:fld id="{5C634AAC-F929-794D-9D03-D362D65357EB}" type="datetimeFigureOut">
               <a:rPr lang="en-NL" smtClean="0"/>
-              <a:t>07/10/2026</a:t>
+              <a:t>10/10/2026</a:t>
             </a:fld>
             <a:endParaRPr lang="en-NL"/>
           </a:p>
@@ -3477,7 +3486,310 @@
   <p:cSld>
     <p:spTree>
       <p:nvGrpSpPr>
+        <p:cNvPr id="1" name="">
+          <a:extLst>
+            <a:ext uri="{FF2B5EF4-FFF2-40B4-BE49-F238E27FC236}">
+              <a16:creationId xmlns:a16="http://schemas.microsoft.com/office/drawing/2014/main" id="{35348B5C-62CF-436F-EC67-AA68C1E03BCC}"/>
+            </a:ext>
+          </a:extLst>
+        </p:cNvPr>
+        <p:cNvGrpSpPr/>
+        <p:nvPr/>
+      </p:nvGrpSpPr>
+      <p:grpSpPr>
+        <a:xfrm>
+          <a:off x="0" y="0"/>
+          <a:ext cx="0" cy="0"/>
+          <a:chOff x="0" y="0"/>
+          <a:chExt cx="0" cy="0"/>
+        </a:xfrm>
+      </p:grpSpPr>
+      <p:sp>
+        <p:nvSpPr>
+          <p:cNvPr id="4" name="Title 3">
+            <a:extLst>
+              <a:ext uri="{FF2B5EF4-FFF2-40B4-BE49-F238E27FC236}">
+                <a16:creationId xmlns:a16="http://schemas.microsoft.com/office/drawing/2014/main" id="{C53674BE-55B7-2534-D23C-5ABEDE46AC99}"/>
+              </a:ext>
+            </a:extLst>
+          </p:cNvPr>
+          <p:cNvSpPr>
+            <a:spLocks noGrp="1"/>
+          </p:cNvSpPr>
+          <p:nvPr>
+            <p:ph type="title"/>
+          </p:nvPr>
+        </p:nvSpPr>
+        <p:spPr/>
+        <p:txBody>
+          <a:bodyPr/>
+          <a:lstStyle/>
+          <a:p>
+            <a:r>
+              <a:rPr lang="en-NL" dirty="0"/>
+              <a:t>MIM 2.0 (UML)</a:t>
+            </a:r>
+          </a:p>
+        </p:txBody>
+      </p:sp>
+      <p:sp>
+        <p:nvSpPr>
+          <p:cNvPr id="6" name="TextBox 5">
+            <a:extLst>
+              <a:ext uri="{FF2B5EF4-FFF2-40B4-BE49-F238E27FC236}">
+                <a16:creationId xmlns:a16="http://schemas.microsoft.com/office/drawing/2014/main" id="{A8A7D332-0C97-4562-39E5-F52967C2A528}"/>
+              </a:ext>
+            </a:extLst>
+          </p:cNvPr>
+          <p:cNvSpPr txBox="1"/>
+          <p:nvPr/>
+        </p:nvSpPr>
+        <p:spPr>
+          <a:xfrm>
+            <a:off x="732980" y="4997884"/>
+            <a:ext cx="5179623" cy="369332"/>
+          </a:xfrm>
+          <a:prstGeom prst="rect">
+            <a:avLst/>
+          </a:prstGeom>
+          <a:noFill/>
+        </p:spPr>
+        <p:txBody>
+          <a:bodyPr wrap="none" rtlCol="0">
+            <a:spAutoFit/>
+          </a:bodyPr>
+          <a:lstStyle/>
+          <a:p>
+            <a:r>
+              <a:rPr lang="en-US" dirty="0" err="1"/>
+              <a:t>Reguliere</a:t>
+            </a:r>
+            <a:r>
+              <a:rPr lang="en-US" dirty="0"/>
+              <a:t> </a:t>
+            </a:r>
+            <a:r>
+              <a:rPr lang="en-US" dirty="0" err="1"/>
+              <a:t>relatie</a:t>
+            </a:r>
+            <a:r>
+              <a:rPr lang="en-US" dirty="0"/>
+              <a:t>, </a:t>
+            </a:r>
+            <a:r>
+              <a:rPr lang="en-US" dirty="0" err="1"/>
+              <a:t>zonder</a:t>
+            </a:r>
+            <a:r>
+              <a:rPr lang="en-US" dirty="0"/>
+              <a:t> </a:t>
+            </a:r>
+            <a:r>
+              <a:rPr lang="en-US" dirty="0" err="1"/>
+              <a:t>eigenschappen</a:t>
+            </a:r>
+            <a:r>
+              <a:rPr lang="en-US" dirty="0"/>
+              <a:t> of </a:t>
+            </a:r>
+            <a:r>
+              <a:rPr lang="en-US" dirty="0" err="1"/>
+              <a:t>relaties</a:t>
+            </a:r>
+            <a:endParaRPr lang="en-NL" dirty="0"/>
+          </a:p>
+        </p:txBody>
+      </p:sp>
+      <p:pic>
+        <p:nvPicPr>
+          <p:cNvPr id="10" name="Graphic 9">
+            <a:extLst>
+              <a:ext uri="{FF2B5EF4-FFF2-40B4-BE49-F238E27FC236}">
+                <a16:creationId xmlns:a16="http://schemas.microsoft.com/office/drawing/2014/main" id="{C19F2E53-4898-F2F8-C31A-318042BFA4A5}"/>
+              </a:ext>
+            </a:extLst>
+          </p:cNvPr>
+          <p:cNvPicPr>
+            <a:picLocks noChangeAspect="1"/>
+          </p:cNvPicPr>
+          <p:nvPr/>
+        </p:nvPicPr>
+        <p:blipFill>
+          <a:blip>
+            <a:extLst>
+              <a:ext uri="{96DAC541-7B7A-43D3-8B79-37D633B846F1}">
+                <asvg:svgBlip xmlns:asvg="http://schemas.microsoft.com/office/drawing/2016/SVG/main" r:embed="rId2"/>
+              </a:ext>
+            </a:extLst>
+          </a:blip>
+          <a:stretch>
+            <a:fillRect/>
+          </a:stretch>
+        </p:blipFill>
+        <p:spPr>
+          <a:xfrm>
+            <a:off x="1287136" y="2353314"/>
+            <a:ext cx="9250934" cy="1567434"/>
+          </a:xfrm>
+          <a:prstGeom prst="rect">
+            <a:avLst/>
+          </a:prstGeom>
+        </p:spPr>
+      </p:pic>
+    </p:spTree>
+    <p:extLst>
+      <p:ext uri="{BB962C8B-B14F-4D97-AF65-F5344CB8AC3E}">
+        <p14:creationId xmlns:p14="http://schemas.microsoft.com/office/powerpoint/2010/main" val="170671596"/>
+      </p:ext>
+    </p:extLst>
+  </p:cSld>
+  <p:clrMapOvr>
+    <a:masterClrMapping/>
+  </p:clrMapOvr>
+</p:sld>
+</file>
+
+<file path=ppt/slides/slide3.xml><?xml version="1.0" encoding="utf-8"?>
+<p:sld xmlns:a="http://schemas.openxmlformats.org/drawingml/2006/main" xmlns:r="http://schemas.openxmlformats.org/officeDocument/2006/relationships" xmlns:p="http://schemas.openxmlformats.org/presentationml/2006/main">
+  <p:cSld>
+    <p:spTree>
+      <p:nvGrpSpPr>
         <p:cNvPr id="1" name=""/>
+        <p:cNvGrpSpPr/>
+        <p:nvPr/>
+      </p:nvGrpSpPr>
+      <p:grpSpPr>
+        <a:xfrm>
+          <a:off x="0" y="0"/>
+          <a:ext cx="0" cy="0"/>
+          <a:chOff x="0" y="0"/>
+          <a:chExt cx="0" cy="0"/>
+        </a:xfrm>
+      </p:grpSpPr>
+      <p:sp>
+        <p:nvSpPr>
+          <p:cNvPr id="4" name="Title 3">
+            <a:extLst>
+              <a:ext uri="{FF2B5EF4-FFF2-40B4-BE49-F238E27FC236}">
+                <a16:creationId xmlns:a16="http://schemas.microsoft.com/office/drawing/2014/main" id="{2AB05149-2D0B-D740-2AD3-73E406A158DF}"/>
+              </a:ext>
+            </a:extLst>
+          </p:cNvPr>
+          <p:cNvSpPr>
+            <a:spLocks noGrp="1"/>
+          </p:cNvSpPr>
+          <p:nvPr>
+            <p:ph type="title"/>
+          </p:nvPr>
+        </p:nvSpPr>
+        <p:spPr/>
+        <p:txBody>
+          <a:bodyPr/>
+          <a:lstStyle/>
+          <a:p>
+            <a:r>
+              <a:rPr lang="en-NL" dirty="0"/>
+              <a:t>Feitmodel</a:t>
+            </a:r>
+          </a:p>
+        </p:txBody>
+      </p:sp>
+      <p:pic>
+        <p:nvPicPr>
+          <p:cNvPr id="3" name="Graphic 2">
+            <a:extLst>
+              <a:ext uri="{FF2B5EF4-FFF2-40B4-BE49-F238E27FC236}">
+                <a16:creationId xmlns:a16="http://schemas.microsoft.com/office/drawing/2014/main" id="{B643D238-E73B-23FD-DC43-935BC9E36AFB}"/>
+              </a:ext>
+            </a:extLst>
+          </p:cNvPr>
+          <p:cNvPicPr>
+            <a:picLocks noChangeAspect="1"/>
+          </p:cNvPicPr>
+          <p:nvPr/>
+        </p:nvPicPr>
+        <p:blipFill>
+          <a:blip>
+            <a:extLst>
+              <a:ext uri="{96DAC541-7B7A-43D3-8B79-37D633B846F1}">
+                <asvg:svgBlip xmlns:asvg="http://schemas.microsoft.com/office/drawing/2016/SVG/main" r:embed="rId2"/>
+              </a:ext>
+            </a:extLst>
+          </a:blip>
+          <a:stretch>
+            <a:fillRect/>
+          </a:stretch>
+        </p:blipFill>
+        <p:spPr>
+          <a:xfrm>
+            <a:off x="432000" y="2492994"/>
+            <a:ext cx="11329200" cy="2265840"/>
+          </a:xfrm>
+          <a:prstGeom prst="rect">
+            <a:avLst/>
+          </a:prstGeom>
+        </p:spPr>
+      </p:pic>
+      <p:sp>
+        <p:nvSpPr>
+          <p:cNvPr id="5" name="TextBox 4">
+            <a:extLst>
+              <a:ext uri="{FF2B5EF4-FFF2-40B4-BE49-F238E27FC236}">
+                <a16:creationId xmlns:a16="http://schemas.microsoft.com/office/drawing/2014/main" id="{5F392C25-515C-935F-0436-5D06A78945CB}"/>
+              </a:ext>
+            </a:extLst>
+          </p:cNvPr>
+          <p:cNvSpPr txBox="1"/>
+          <p:nvPr/>
+        </p:nvSpPr>
+        <p:spPr>
+          <a:xfrm>
+            <a:off x="430714" y="5414963"/>
+            <a:ext cx="5312862" cy="646331"/>
+          </a:xfrm>
+          <a:prstGeom prst="rect">
+            <a:avLst/>
+          </a:prstGeom>
+          <a:noFill/>
+        </p:spPr>
+        <p:txBody>
+          <a:bodyPr wrap="square" rtlCol="0">
+            <a:spAutoFit/>
+          </a:bodyPr>
+          <a:lstStyle/>
+          <a:p>
+            <a:r>
+              <a:rPr lang="en-NL" dirty="0"/>
+              <a:t>Dienstbetrekking als regulier feittype tussen twee objecttypen, komt overeen met mim:Relatietype</a:t>
+            </a:r>
+          </a:p>
+        </p:txBody>
+      </p:sp>
+    </p:spTree>
+    <p:extLst>
+      <p:ext uri="{BB962C8B-B14F-4D97-AF65-F5344CB8AC3E}">
+        <p14:creationId xmlns:p14="http://schemas.microsoft.com/office/powerpoint/2010/main" val="1846609394"/>
+      </p:ext>
+    </p:extLst>
+  </p:cSld>
+  <p:clrMapOvr>
+    <a:masterClrMapping/>
+  </p:clrMapOvr>
+</p:sld>
+</file>
+
+<file path=ppt/slides/slide4.xml><?xml version="1.0" encoding="utf-8"?>
+<p:sld xmlns:a="http://schemas.openxmlformats.org/drawingml/2006/main" xmlns:r="http://schemas.openxmlformats.org/officeDocument/2006/relationships" xmlns:p="http://schemas.openxmlformats.org/presentationml/2006/main">
+  <p:cSld>
+    <p:spTree>
+      <p:nvGrpSpPr>
+        <p:cNvPr id="1" name="">
+          <a:extLst>
+            <a:ext uri="{FF2B5EF4-FFF2-40B4-BE49-F238E27FC236}">
+              <a16:creationId xmlns:a16="http://schemas.microsoft.com/office/drawing/2014/main" id="{2CE16F3F-6E0A-0D19-0037-B901C1BE8C30}"/>
+            </a:ext>
+          </a:extLst>
+        </p:cNvPr>
         <p:cNvGrpSpPr/>
         <p:nvPr/>
       </p:nvGrpSpPr>
@@ -3494,7 +3806,7 @@
           <p:cNvPr id="6" name="Graphic 5">
             <a:extLst>
               <a:ext uri="{FF2B5EF4-FFF2-40B4-BE49-F238E27FC236}">
-                <a16:creationId xmlns:a16="http://schemas.microsoft.com/office/drawing/2014/main" id="{5EB9BF84-EB97-0222-0372-23AF667ABA38}"/>
+                <a16:creationId xmlns:a16="http://schemas.microsoft.com/office/drawing/2014/main" id="{F80104A9-B103-094C-CB3C-AD973459F3FF}"/>
               </a:ext>
             </a:extLst>
           </p:cNvPr>
@@ -3518,7 +3830,7 @@
         <p:spPr>
           <a:xfrm>
             <a:off x="430713" y="683381"/>
-            <a:ext cx="11330574" cy="5809494"/>
+            <a:ext cx="11329200" cy="5808790"/>
           </a:xfrm>
           <a:prstGeom prst="rect">
             <a:avLst/>
@@ -3530,7 +3842,7 @@
           <p:cNvPr id="4" name="Title 3">
             <a:extLst>
               <a:ext uri="{FF2B5EF4-FFF2-40B4-BE49-F238E27FC236}">
-                <a16:creationId xmlns:a16="http://schemas.microsoft.com/office/drawing/2014/main" id="{2AB05149-2D0B-D740-2AD3-73E406A158DF}"/>
+                <a16:creationId xmlns:a16="http://schemas.microsoft.com/office/drawing/2014/main" id="{2820B5C1-F3B4-D1F3-4A71-B626C80B4CEF}"/>
               </a:ext>
             </a:extLst>
           </p:cNvPr>
@@ -3558,7 +3870,7 @@
           <p:cNvPr id="7" name="TextBox 6">
             <a:extLst>
               <a:ext uri="{FF2B5EF4-FFF2-40B4-BE49-F238E27FC236}">
-                <a16:creationId xmlns:a16="http://schemas.microsoft.com/office/drawing/2014/main" id="{70D02B70-47ED-D576-BCB8-0A051D78EC85}"/>
+                <a16:creationId xmlns:a16="http://schemas.microsoft.com/office/drawing/2014/main" id="{B8534AA7-E612-3CFD-2738-7983D66D1CD3}"/>
               </a:ext>
             </a:extLst>
           </p:cNvPr>
@@ -3601,7 +3913,7 @@
     </p:spTree>
     <p:extLst>
       <p:ext uri="{BB962C8B-B14F-4D97-AF65-F5344CB8AC3E}">
-        <p14:creationId xmlns:p14="http://schemas.microsoft.com/office/powerpoint/2010/main" val="1846609394"/>
+        <p14:creationId xmlns:p14="http://schemas.microsoft.com/office/powerpoint/2010/main" val="717146078"/>
       </p:ext>
     </p:extLst>
   </p:cSld>
@@ -3611,7 +3923,7 @@
 </p:sld>
 </file>
 
-<file path=ppt/slides/slide3.xml><?xml version="1.0" encoding="utf-8"?>
+<file path=ppt/slides/slide5.xml><?xml version="1.0" encoding="utf-8"?>
 <p:sld xmlns:a="http://schemas.openxmlformats.org/drawingml/2006/main" xmlns:r="http://schemas.openxmlformats.org/officeDocument/2006/relationships" xmlns:p="http://schemas.openxmlformats.org/presentationml/2006/main">
   <p:cSld>
     <p:spTree>
@@ -4059,10 +4371,10 @@
       </p:sp>
       <p:pic>
         <p:nvPicPr>
-          <p:cNvPr id="8" name="Graphic 7">
-            <a:extLst>
-              <a:ext uri="{FF2B5EF4-FFF2-40B4-BE49-F238E27FC236}">
-                <a16:creationId xmlns:a16="http://schemas.microsoft.com/office/drawing/2014/main" id="{4EFF5CFF-913D-2BA5-DD5A-A2A2621AEC06}"/>
+          <p:cNvPr id="17" name="Graphic 16">
+            <a:extLst>
+              <a:ext uri="{FF2B5EF4-FFF2-40B4-BE49-F238E27FC236}">
+                <a16:creationId xmlns:a16="http://schemas.microsoft.com/office/drawing/2014/main" id="{B5ED391B-699A-569A-0479-1605B8DFD3A2}"/>
               </a:ext>
             </a:extLst>
           </p:cNvPr>
@@ -4085,8 +4397,8 @@
         </p:blipFill>
         <p:spPr>
           <a:xfrm>
-            <a:off x="104913" y="1543044"/>
-            <a:ext cx="11864937" cy="3169085"/>
+            <a:off x="16416" y="1490597"/>
+            <a:ext cx="12185712" cy="3106455"/>
           </a:xfrm>
           <a:prstGeom prst="rect">
             <a:avLst/>
@@ -4106,7 +4418,398 @@
 </p:sld>
 </file>
 
-<file path=ppt/slides/slide4.xml><?xml version="1.0" encoding="utf-8"?>
+<file path=ppt/slides/slide6.xml><?xml version="1.0" encoding="utf-8"?>
+<p:sld xmlns:a="http://schemas.openxmlformats.org/drawingml/2006/main" xmlns:r="http://schemas.openxmlformats.org/officeDocument/2006/relationships" xmlns:p="http://schemas.openxmlformats.org/presentationml/2006/main">
+  <p:cSld>
+    <p:spTree>
+      <p:nvGrpSpPr>
+        <p:cNvPr id="1" name="">
+          <a:extLst>
+            <a:ext uri="{FF2B5EF4-FFF2-40B4-BE49-F238E27FC236}">
+              <a16:creationId xmlns:a16="http://schemas.microsoft.com/office/drawing/2014/main" id="{5441A7E8-DA7A-020C-8716-DD96E3D9518C}"/>
+            </a:ext>
+          </a:extLst>
+        </p:cNvPr>
+        <p:cNvGrpSpPr/>
+        <p:nvPr/>
+      </p:nvGrpSpPr>
+      <p:grpSpPr>
+        <a:xfrm>
+          <a:off x="0" y="0"/>
+          <a:ext cx="0" cy="0"/>
+          <a:chOff x="0" y="0"/>
+          <a:chExt cx="0" cy="0"/>
+        </a:xfrm>
+      </p:grpSpPr>
+      <p:sp>
+        <p:nvSpPr>
+          <p:cNvPr id="4" name="Title 3">
+            <a:extLst>
+              <a:ext uri="{FF2B5EF4-FFF2-40B4-BE49-F238E27FC236}">
+                <a16:creationId xmlns:a16="http://schemas.microsoft.com/office/drawing/2014/main" id="{28CAD2E8-BCE2-1EDC-65F3-16A028AFA5FC}"/>
+              </a:ext>
+            </a:extLst>
+          </p:cNvPr>
+          <p:cNvSpPr>
+            <a:spLocks noGrp="1"/>
+          </p:cNvSpPr>
+          <p:nvPr>
+            <p:ph type="title"/>
+          </p:nvPr>
+        </p:nvSpPr>
+        <p:spPr/>
+        <p:txBody>
+          <a:bodyPr/>
+          <a:lstStyle/>
+          <a:p>
+            <a:r>
+              <a:rPr lang="en-NL" dirty="0"/>
+              <a:t>MIM 2.0 (UML)</a:t>
+            </a:r>
+          </a:p>
+        </p:txBody>
+      </p:sp>
+      <p:sp>
+        <p:nvSpPr>
+          <p:cNvPr id="6" name="TextBox 5">
+            <a:extLst>
+              <a:ext uri="{FF2B5EF4-FFF2-40B4-BE49-F238E27FC236}">
+                <a16:creationId xmlns:a16="http://schemas.microsoft.com/office/drawing/2014/main" id="{8F9B441D-9059-EF46-175D-0C9A84386CB7}"/>
+              </a:ext>
+            </a:extLst>
+          </p:cNvPr>
+          <p:cNvSpPr txBox="1"/>
+          <p:nvPr/>
+        </p:nvSpPr>
+        <p:spPr>
+          <a:xfrm>
+            <a:off x="732980" y="4997884"/>
+            <a:ext cx="9141926" cy="923330"/>
+          </a:xfrm>
+          <a:prstGeom prst="rect">
+            <a:avLst/>
+          </a:prstGeom>
+          <a:noFill/>
+        </p:spPr>
+        <p:txBody>
+          <a:bodyPr wrap="none" rtlCol="0">
+            <a:spAutoFit/>
+          </a:bodyPr>
+          <a:lstStyle/>
+          <a:p>
+            <a:r>
+              <a:rPr lang="en-US" dirty="0" err="1"/>
+              <a:t>Aanpassing</a:t>
+            </a:r>
+            <a:r>
+              <a:rPr lang="en-US" dirty="0"/>
+              <a:t>:</a:t>
+            </a:r>
+          </a:p>
+          <a:p>
+            <a:pPr marL="285750" indent="-285750">
+              <a:buFontTx/>
+              <a:buChar char="-"/>
+            </a:pPr>
+            <a:r>
+              <a:rPr lang="en-US" dirty="0"/>
+              <a:t>Een “</a:t>
+            </a:r>
+            <a:r>
+              <a:rPr lang="en-US" dirty="0" err="1"/>
+              <a:t>echte</a:t>
+            </a:r>
+            <a:r>
+              <a:rPr lang="en-US" dirty="0"/>
+              <a:t>” </a:t>
+            </a:r>
+            <a:r>
+              <a:rPr lang="en-US" dirty="0" err="1"/>
+              <a:t>relatie</a:t>
+            </a:r>
+            <a:r>
+              <a:rPr lang="en-US" dirty="0"/>
+              <a:t> </a:t>
+            </a:r>
+            <a:r>
+              <a:rPr lang="en-US" dirty="0" err="1"/>
+              <a:t>tussen</a:t>
+            </a:r>
+            <a:r>
+              <a:rPr lang="en-US" dirty="0"/>
+              <a:t> </a:t>
+            </a:r>
+            <a:r>
+              <a:rPr lang="en-US" dirty="0" err="1"/>
+              <a:t>dienstbetrekking</a:t>
+            </a:r>
+            <a:r>
+              <a:rPr lang="en-US" dirty="0"/>
+              <a:t> </a:t>
+            </a:r>
+            <a:r>
+              <a:rPr lang="en-US" dirty="0" err="1"/>
+              <a:t>en</a:t>
+            </a:r>
+            <a:r>
+              <a:rPr lang="en-US" dirty="0"/>
+              <a:t> </a:t>
+            </a:r>
+            <a:r>
+              <a:rPr lang="en-US" dirty="0" err="1"/>
+              <a:t>arbeidscontract</a:t>
+            </a:r>
+            <a:r>
+              <a:rPr lang="en-US" dirty="0"/>
+              <a:t>;</a:t>
+            </a:r>
+          </a:p>
+          <a:p>
+            <a:pPr marL="285750" indent="-285750">
+              <a:buFontTx/>
+              <a:buChar char="-"/>
+            </a:pPr>
+            <a:r>
+              <a:rPr lang="en-US" dirty="0" err="1"/>
+              <a:t>Identificator</a:t>
+            </a:r>
+            <a:r>
+              <a:rPr lang="en-US" dirty="0"/>
+              <a:t> van </a:t>
+            </a:r>
+            <a:r>
+              <a:rPr lang="en-US" dirty="0" err="1"/>
+              <a:t>arbeidscontract</a:t>
+            </a:r>
+            <a:r>
+              <a:rPr lang="en-US" dirty="0"/>
+              <a:t> </a:t>
+            </a:r>
+            <a:r>
+              <a:rPr lang="en-US" dirty="0" err="1"/>
+              <a:t>aangepast</a:t>
+            </a:r>
+            <a:r>
+              <a:rPr lang="en-US" dirty="0"/>
+              <a:t>: </a:t>
+            </a:r>
+            <a:r>
+              <a:rPr lang="en-US" dirty="0" err="1"/>
+              <a:t>arbeidscontract</a:t>
+            </a:r>
+            <a:r>
+              <a:rPr lang="en-US" dirty="0"/>
+              <a:t> is nu </a:t>
+            </a:r>
+            <a:r>
+              <a:rPr lang="en-US" dirty="0" err="1"/>
+              <a:t>niet</a:t>
+            </a:r>
+            <a:r>
+              <a:rPr lang="en-US" dirty="0"/>
+              <a:t> </a:t>
+            </a:r>
+            <a:r>
+              <a:rPr lang="en-US" dirty="0" err="1"/>
+              <a:t>meer</a:t>
+            </a:r>
+            <a:r>
+              <a:rPr lang="en-US" dirty="0"/>
+              <a:t> </a:t>
+            </a:r>
+            <a:r>
+              <a:rPr lang="en-US" dirty="0" err="1"/>
+              <a:t>afhankelijk</a:t>
+            </a:r>
+            <a:endParaRPr lang="en-NL" dirty="0"/>
+          </a:p>
+        </p:txBody>
+      </p:sp>
+      <p:pic>
+        <p:nvPicPr>
+          <p:cNvPr id="5" name="Graphic 4">
+            <a:extLst>
+              <a:ext uri="{FF2B5EF4-FFF2-40B4-BE49-F238E27FC236}">
+                <a16:creationId xmlns:a16="http://schemas.microsoft.com/office/drawing/2014/main" id="{D69C700D-9AE9-AE8E-7860-5A332BFFDBD1}"/>
+              </a:ext>
+            </a:extLst>
+          </p:cNvPr>
+          <p:cNvPicPr>
+            <a:picLocks noChangeAspect="1"/>
+          </p:cNvPicPr>
+          <p:nvPr/>
+        </p:nvPicPr>
+        <p:blipFill>
+          <a:blip>
+            <a:extLst>
+              <a:ext uri="{96DAC541-7B7A-43D3-8B79-37D633B846F1}">
+                <asvg:svgBlip xmlns:asvg="http://schemas.microsoft.com/office/drawing/2016/SVG/main" r:embed="rId2"/>
+              </a:ext>
+            </a:extLst>
+          </a:blip>
+          <a:stretch>
+            <a:fillRect/>
+          </a:stretch>
+        </p:blipFill>
+        <p:spPr>
+          <a:xfrm>
+            <a:off x="16416" y="1490597"/>
+            <a:ext cx="12185712" cy="3106455"/>
+          </a:xfrm>
+          <a:prstGeom prst="rect">
+            <a:avLst/>
+          </a:prstGeom>
+        </p:spPr>
+      </p:pic>
+    </p:spTree>
+    <p:extLst>
+      <p:ext uri="{BB962C8B-B14F-4D97-AF65-F5344CB8AC3E}">
+        <p14:creationId xmlns:p14="http://schemas.microsoft.com/office/powerpoint/2010/main" val="2638436952"/>
+      </p:ext>
+    </p:extLst>
+  </p:cSld>
+  <p:clrMapOvr>
+    <a:masterClrMapping/>
+  </p:clrMapOvr>
+</p:sld>
+</file>
+
+<file path=ppt/slides/slide7.xml><?xml version="1.0" encoding="utf-8"?>
+<p:sld xmlns:a="http://schemas.openxmlformats.org/drawingml/2006/main" xmlns:r="http://schemas.openxmlformats.org/officeDocument/2006/relationships" xmlns:p="http://schemas.openxmlformats.org/presentationml/2006/main">
+  <p:cSld>
+    <p:spTree>
+      <p:nvGrpSpPr>
+        <p:cNvPr id="1" name="">
+          <a:extLst>
+            <a:ext uri="{FF2B5EF4-FFF2-40B4-BE49-F238E27FC236}">
+              <a16:creationId xmlns:a16="http://schemas.microsoft.com/office/drawing/2014/main" id="{939874CD-C10A-0D01-4407-E1FFBBE5C652}"/>
+            </a:ext>
+          </a:extLst>
+        </p:cNvPr>
+        <p:cNvGrpSpPr/>
+        <p:nvPr/>
+      </p:nvGrpSpPr>
+      <p:grpSpPr>
+        <a:xfrm>
+          <a:off x="0" y="0"/>
+          <a:ext cx="0" cy="0"/>
+          <a:chOff x="0" y="0"/>
+          <a:chExt cx="0" cy="0"/>
+        </a:xfrm>
+      </p:grpSpPr>
+      <p:pic>
+        <p:nvPicPr>
+          <p:cNvPr id="5" name="Graphic 4">
+            <a:extLst>
+              <a:ext uri="{FF2B5EF4-FFF2-40B4-BE49-F238E27FC236}">
+                <a16:creationId xmlns:a16="http://schemas.microsoft.com/office/drawing/2014/main" id="{C40728B7-9C23-5398-496B-C8C06F5C9780}"/>
+              </a:ext>
+            </a:extLst>
+          </p:cNvPr>
+          <p:cNvPicPr>
+            <a:picLocks noChangeAspect="1"/>
+          </p:cNvPicPr>
+          <p:nvPr/>
+        </p:nvPicPr>
+        <p:blipFill>
+          <a:blip>
+            <a:extLst>
+              <a:ext uri="{96DAC541-7B7A-43D3-8B79-37D633B846F1}">
+                <asvg:svgBlip xmlns:asvg="http://schemas.microsoft.com/office/drawing/2016/SVG/main" r:embed="rId2"/>
+              </a:ext>
+            </a:extLst>
+          </a:blip>
+          <a:stretch>
+            <a:fillRect/>
+          </a:stretch>
+        </p:blipFill>
+        <p:spPr>
+          <a:xfrm>
+            <a:off x="527216" y="242708"/>
+            <a:ext cx="11232697" cy="6249463"/>
+          </a:xfrm>
+          <a:prstGeom prst="rect">
+            <a:avLst/>
+          </a:prstGeom>
+        </p:spPr>
+      </p:pic>
+      <p:sp>
+        <p:nvSpPr>
+          <p:cNvPr id="4" name="Title 3">
+            <a:extLst>
+              <a:ext uri="{FF2B5EF4-FFF2-40B4-BE49-F238E27FC236}">
+                <a16:creationId xmlns:a16="http://schemas.microsoft.com/office/drawing/2014/main" id="{14E975BE-BEB1-6A10-CC0D-1118D105B6F9}"/>
+              </a:ext>
+            </a:extLst>
+          </p:cNvPr>
+          <p:cNvSpPr>
+            <a:spLocks noGrp="1"/>
+          </p:cNvSpPr>
+          <p:nvPr>
+            <p:ph type="title"/>
+          </p:nvPr>
+        </p:nvSpPr>
+        <p:spPr/>
+        <p:txBody>
+          <a:bodyPr/>
+          <a:lstStyle/>
+          <a:p>
+            <a:r>
+              <a:rPr lang="en-NL" dirty="0"/>
+              <a:t>Feitmodel</a:t>
+            </a:r>
+          </a:p>
+        </p:txBody>
+      </p:sp>
+      <p:sp>
+        <p:nvSpPr>
+          <p:cNvPr id="7" name="TextBox 6">
+            <a:extLst>
+              <a:ext uri="{FF2B5EF4-FFF2-40B4-BE49-F238E27FC236}">
+                <a16:creationId xmlns:a16="http://schemas.microsoft.com/office/drawing/2014/main" id="{8D0E51DE-7775-E009-4155-815A7CFC1078}"/>
+              </a:ext>
+            </a:extLst>
+          </p:cNvPr>
+          <p:cNvSpPr txBox="1"/>
+          <p:nvPr/>
+        </p:nvSpPr>
+        <p:spPr>
+          <a:xfrm>
+            <a:off x="430714" y="5414963"/>
+            <a:ext cx="5312862" cy="923330"/>
+          </a:xfrm>
+          <a:prstGeom prst="rect">
+            <a:avLst/>
+          </a:prstGeom>
+          <a:noFill/>
+        </p:spPr>
+        <p:txBody>
+          <a:bodyPr wrap="square" rtlCol="0">
+            <a:spAutoFit/>
+          </a:bodyPr>
+          <a:lstStyle/>
+          <a:p>
+            <a:r>
+              <a:rPr lang="en-NL" dirty="0"/>
+              <a:t>Het feitmodel krijgt hierdoor een extra feittype tussen het arbeidscontract (met een eigen identificator) en dienstbetrekking</a:t>
+            </a:r>
+          </a:p>
+        </p:txBody>
+      </p:sp>
+    </p:spTree>
+    <p:extLst>
+      <p:ext uri="{BB962C8B-B14F-4D97-AF65-F5344CB8AC3E}">
+        <p14:creationId xmlns:p14="http://schemas.microsoft.com/office/powerpoint/2010/main" val="1542906920"/>
+      </p:ext>
+    </p:extLst>
+  </p:cSld>
+  <p:clrMapOvr>
+    <a:masterClrMapping/>
+  </p:clrMapOvr>
+</p:sld>
+</file>
+
+<file path=ppt/slides/slide8.xml><?xml version="1.0" encoding="utf-8"?>
 <p:sld xmlns:a="http://schemas.openxmlformats.org/drawingml/2006/main" xmlns:r="http://schemas.openxmlformats.org/officeDocument/2006/relationships" xmlns:p="http://schemas.openxmlformats.org/presentationml/2006/main">
   <p:cSld>
     <p:spTree>
@@ -4277,7 +4980,7 @@
 </p:sld>
 </file>
 
-<file path=ppt/slides/slide5.xml><?xml version="1.0" encoding="utf-8"?>
+<file path=ppt/slides/slide9.xml><?xml version="1.0" encoding="utf-8"?>
 <p:sld xmlns:a="http://schemas.openxmlformats.org/drawingml/2006/main" xmlns:r="http://schemas.openxmlformats.org/officeDocument/2006/relationships" xmlns:p="http://schemas.openxmlformats.org/presentationml/2006/main">
   <p:cSld>
     <p:spTree>

</xml_diff>